<commit_message>
#28 e correção do banner
</commit_message>
<xml_diff>
--- a/documentos/Banner_FECAP_CCOMP4_Radonix.pptx
+++ b/documentos/Banner_FECAP_CCOMP4_Radonix.pptx
@@ -4224,7 +4224,7 @@
                 <a:ea typeface="ＭＳ Ｐゴシック" pitchFamily="34" charset="-128"/>
                 <a:cs typeface="Times New Roman" pitchFamily="18" charset="0"/>
               </a:rPr>
-              <a:t> Gabriel Carvalho Mota - Guilherme de Lima Siqueira - Rodrigo Luiz Menezes dos Reis - Vitória Leticia Maciel da Silva</a:t>
+              <a:t> Gabriel Carvalho Mota   Guilherme de Lima Siqueira   Rodrigo Luiz Menezes dos Reis   Vitória Leticia Maciel da Silva</a:t>
             </a:r>
           </a:p>
         </p:txBody>
@@ -4801,7 +4801,7 @@
         </p:nvSpPr>
         <p:spPr bwMode="auto">
           <a:xfrm>
-            <a:off x="630353" y="32689551"/>
+            <a:off x="630353" y="33543418"/>
             <a:ext cx="13318910" cy="7283982"/>
           </a:xfrm>
           <a:prstGeom prst="rect">
@@ -5197,7 +5197,7 @@
         </p:nvSpPr>
         <p:spPr bwMode="auto">
           <a:xfrm>
-            <a:off x="14566876" y="32692804"/>
+            <a:off x="14566876" y="33546671"/>
             <a:ext cx="13318910" cy="4175438"/>
           </a:xfrm>
           <a:prstGeom prst="rect">
@@ -5294,8 +5294,8 @@
         </p:nvSpPr>
         <p:spPr bwMode="auto">
           <a:xfrm>
-            <a:off x="14680583" y="10386412"/>
-            <a:ext cx="12868819" cy="1569469"/>
+            <a:off x="7929068" y="13404503"/>
+            <a:ext cx="12868819" cy="995016"/>
           </a:xfrm>
           <a:prstGeom prst="rect">
             <a:avLst/>
@@ -5336,21 +5336,6 @@
                 <a:ea typeface="ＭＳ Ｐゴシック" pitchFamily="34" charset="-128"/>
               </a:rPr>
               <a:t>Imagens e ferramentas do Projeto</a:t>
-            </a:r>
-          </a:p>
-          <a:p>
-            <a:pPr algn="just" defTabSz="1678349" eaLnBrk="1" hangingPunct="1">
-              <a:spcAft>
-                <a:spcPts val="1200"/>
-              </a:spcAft>
-            </a:pPr>
-            <a:r>
-              <a:rPr lang="pt-BR" sz="3733" dirty="0"/>
-              <a:t> </a:t>
-            </a:r>
-            <a:r>
-              <a:rPr lang="pt-BR" sz="2666" dirty="0"/>
-              <a:t>	</a:t>
             </a:r>
           </a:p>
         </p:txBody>
@@ -5455,7 +5440,7 @@
         </p:blipFill>
         <p:spPr>
           <a:xfrm>
-            <a:off x="25308128" y="13768172"/>
+            <a:off x="25068648" y="15169787"/>
             <a:ext cx="2391362" cy="1235437"/>
           </a:xfrm>
           <a:prstGeom prst="rect">
@@ -5491,7 +5476,7 @@
         </p:blipFill>
         <p:spPr>
           <a:xfrm>
-            <a:off x="25565557" y="12404644"/>
+            <a:off x="11813210" y="15449454"/>
             <a:ext cx="1699135" cy="1274351"/>
           </a:xfrm>
           <a:prstGeom prst="rect">
@@ -5527,7 +5512,7 @@
         </p:blipFill>
         <p:spPr>
           <a:xfrm>
-            <a:off x="2937237" y="11735226"/>
+            <a:off x="10252971" y="10552245"/>
             <a:ext cx="1884969" cy="1884969"/>
           </a:xfrm>
           <a:prstGeom prst="ellipse">
@@ -5569,7 +5554,7 @@
         </p:blipFill>
         <p:spPr>
           <a:xfrm>
-            <a:off x="5059100" y="11735225"/>
+            <a:off x="12374834" y="10552244"/>
             <a:ext cx="1884970" cy="1884970"/>
           </a:xfrm>
           <a:prstGeom prst="ellipse">
@@ -5611,7 +5596,7 @@
         </p:blipFill>
         <p:spPr>
           <a:xfrm>
-            <a:off x="7084478" y="11735225"/>
+            <a:off x="14400212" y="10552244"/>
             <a:ext cx="1884971" cy="1884971"/>
           </a:xfrm>
           <a:prstGeom prst="ellipse">
@@ -5653,7 +5638,7 @@
         </p:blipFill>
         <p:spPr>
           <a:xfrm>
-            <a:off x="9100304" y="11735223"/>
+            <a:off x="16416038" y="10552242"/>
             <a:ext cx="1884972" cy="1884972"/>
           </a:xfrm>
           <a:prstGeom prst="ellipse">
@@ -5683,7 +5668,7 @@
         </p:nvSpPr>
         <p:spPr bwMode="auto">
           <a:xfrm>
-            <a:off x="3295050" y="13582948"/>
+            <a:off x="10610784" y="12399967"/>
             <a:ext cx="1097069" cy="400110"/>
           </a:xfrm>
           <a:prstGeom prst="rect">
@@ -5758,7 +5743,7 @@
         </p:nvSpPr>
         <p:spPr bwMode="auto">
           <a:xfrm>
-            <a:off x="5152271" y="13598214"/>
+            <a:off x="12468005" y="12415233"/>
             <a:ext cx="1598784" cy="400110"/>
           </a:xfrm>
           <a:prstGeom prst="rect">
@@ -5833,7 +5818,7 @@
         </p:nvSpPr>
         <p:spPr bwMode="auto">
           <a:xfrm>
-            <a:off x="7211888" y="13582948"/>
+            <a:off x="14527622" y="12399967"/>
             <a:ext cx="1598784" cy="400110"/>
           </a:xfrm>
           <a:prstGeom prst="rect">
@@ -5896,7 +5881,7 @@
         </p:nvSpPr>
         <p:spPr bwMode="auto">
           <a:xfrm>
-            <a:off x="9271505" y="13587301"/>
+            <a:off x="16587239" y="12404320"/>
             <a:ext cx="1598784" cy="400110"/>
           </a:xfrm>
           <a:prstGeom prst="rect">
@@ -5983,7 +5968,7 @@
         </p:blipFill>
         <p:spPr>
           <a:xfrm>
-            <a:off x="21516796" y="11869442"/>
+            <a:off x="7764449" y="14914252"/>
             <a:ext cx="3879442" cy="2270080"/>
           </a:xfrm>
           <a:prstGeom prst="rect">
@@ -6019,7 +6004,7 @@
         </p:blipFill>
         <p:spPr>
           <a:xfrm>
-            <a:off x="22329865" y="14284543"/>
+            <a:off x="22090385" y="15686158"/>
             <a:ext cx="2208224" cy="1104112"/>
           </a:xfrm>
           <a:prstGeom prst="rect">
@@ -6055,7 +6040,7 @@
         </p:blipFill>
         <p:spPr>
           <a:xfrm>
-            <a:off x="18549785" y="12280141"/>
+            <a:off x="4797438" y="15324951"/>
             <a:ext cx="3049419" cy="1715298"/>
           </a:xfrm>
           <a:prstGeom prst="rect">
@@ -6091,7 +6076,7 @@
         </p:blipFill>
         <p:spPr>
           <a:xfrm>
-            <a:off x="14516706" y="13285936"/>
+            <a:off x="14184188" y="14687551"/>
             <a:ext cx="3650519" cy="2737342"/>
           </a:xfrm>
           <a:prstGeom prst="rect">
@@ -6127,7 +6112,7 @@
         </p:blipFill>
         <p:spPr>
           <a:xfrm>
-            <a:off x="18674323" y="14217097"/>
+            <a:off x="18434843" y="15618712"/>
             <a:ext cx="2914991" cy="1179661"/>
           </a:xfrm>
           <a:prstGeom prst="rect">
@@ -6163,7 +6148,7 @@
         </p:blipFill>
         <p:spPr>
           <a:xfrm>
-            <a:off x="15103750" y="12412019"/>
+            <a:off x="1351403" y="15456829"/>
             <a:ext cx="3276716" cy="1283380"/>
           </a:xfrm>
           <a:prstGeom prst="rect">
@@ -6173,10 +6158,10 @@
       </p:pic>
       <p:pic>
         <p:nvPicPr>
-          <p:cNvPr id="12" name="Imagem 11" descr="Tela de computador com texto preto sobre fundo branco&#10;&#10;O conteúdo gerado por IA pode estar incorreto.">
+          <p:cNvPr id="37" name="Imagem 36">
             <a:extLst>
               <a:ext uri="{FF2B5EF4-FFF2-40B4-BE49-F238E27FC236}">
-                <a16:creationId xmlns:a16="http://schemas.microsoft.com/office/drawing/2014/main" id="{D1BCCAE9-A530-1DEB-4A8C-C283F7CBA66F}"/>
+                <a16:creationId xmlns:a16="http://schemas.microsoft.com/office/drawing/2014/main" id="{E749BE69-CF60-C678-4D0F-9E2D98115990}"/>
               </a:ext>
             </a:extLst>
           </p:cNvPr>
@@ -6186,22 +6171,15 @@
           <p:nvPr/>
         </p:nvPicPr>
         <p:blipFill>
-          <a:blip r:embed="rId18">
-            <a:extLst>
-              <a:ext uri="{28A0092B-C50C-407E-A947-70E740481C1C}">
-                <a14:useLocalDpi xmlns:a14="http://schemas.microsoft.com/office/drawing/2010/main" val="0"/>
-              </a:ext>
-            </a:extLst>
-          </a:blip>
-          <a:srcRect l="10188" r="10309"/>
+          <a:blip r:embed="rId18"/>
           <a:stretch>
             <a:fillRect/>
           </a:stretch>
         </p:blipFill>
         <p:spPr>
           <a:xfrm>
-            <a:off x="14854317" y="16205156"/>
-            <a:ext cx="12653249" cy="7161953"/>
+            <a:off x="14593007" y="25747096"/>
+            <a:ext cx="13606952" cy="6942455"/>
           </a:xfrm>
           <a:prstGeom prst="rect">
             <a:avLst/>
@@ -6210,10 +6188,10 @@
       </p:pic>
       <p:pic>
         <p:nvPicPr>
-          <p:cNvPr id="14" name="Imagem 13" descr="Tela de computador com letras brancas em fundo preto&#10;&#10;O conteúdo gerado por IA pode estar incorreto.">
+          <p:cNvPr id="44" name="Imagem 43">
             <a:extLst>
               <a:ext uri="{FF2B5EF4-FFF2-40B4-BE49-F238E27FC236}">
-                <a16:creationId xmlns:a16="http://schemas.microsoft.com/office/drawing/2014/main" id="{B91E762E-2E8D-14A4-452F-C81A103969DD}"/>
+                <a16:creationId xmlns:a16="http://schemas.microsoft.com/office/drawing/2014/main" id="{BF00E527-D7CF-BB15-8698-4305EB7288B8}"/>
               </a:ext>
             </a:extLst>
           </p:cNvPr>
@@ -6223,22 +6201,15 @@
           <p:nvPr/>
         </p:nvPicPr>
         <p:blipFill>
-          <a:blip r:embed="rId19">
-            <a:extLst>
-              <a:ext uri="{28A0092B-C50C-407E-A947-70E740481C1C}">
-                <a14:useLocalDpi xmlns:a14="http://schemas.microsoft.com/office/drawing/2010/main" val="0"/>
-              </a:ext>
-            </a:extLst>
-          </a:blip>
-          <a:srcRect l="9814" r="10210"/>
+          <a:blip r:embed="rId19"/>
           <a:stretch>
             <a:fillRect/>
           </a:stretch>
         </p:blipFill>
         <p:spPr>
           <a:xfrm>
-            <a:off x="14896152" y="24408495"/>
-            <a:ext cx="12653250" cy="7119641"/>
+            <a:off x="14593006" y="18022587"/>
+            <a:ext cx="13548815" cy="7301341"/>
           </a:xfrm>
           <a:prstGeom prst="rect">
             <a:avLst/>
@@ -6247,10 +6218,10 @@
       </p:pic>
       <p:pic>
         <p:nvPicPr>
-          <p:cNvPr id="17" name="Imagem 16" descr="Logotipo&#10;&#10;O conteúdo gerado por IA pode estar incorreto.">
+          <p:cNvPr id="46" name="Imagem 45">
             <a:extLst>
               <a:ext uri="{FF2B5EF4-FFF2-40B4-BE49-F238E27FC236}">
-                <a16:creationId xmlns:a16="http://schemas.microsoft.com/office/drawing/2014/main" id="{C2B65BEB-7EA6-820B-6814-E75BC676E2A4}"/>
+                <a16:creationId xmlns:a16="http://schemas.microsoft.com/office/drawing/2014/main" id="{EF52C932-E9B4-D0E1-16A1-218095B41B70}"/>
               </a:ext>
             </a:extLst>
           </p:cNvPr>
@@ -6260,22 +6231,15 @@
           <p:nvPr/>
         </p:nvPicPr>
         <p:blipFill>
-          <a:blip r:embed="rId20">
-            <a:extLst>
-              <a:ext uri="{28A0092B-C50C-407E-A947-70E740481C1C}">
-                <a14:useLocalDpi xmlns:a14="http://schemas.microsoft.com/office/drawing/2010/main" val="0"/>
-              </a:ext>
-            </a:extLst>
-          </a:blip>
-          <a:srcRect l="10283" r="9733"/>
+          <a:blip r:embed="rId20"/>
           <a:stretch>
             <a:fillRect/>
           </a:stretch>
         </p:blipFill>
         <p:spPr>
           <a:xfrm>
-            <a:off x="1195696" y="16253662"/>
-            <a:ext cx="12653248" cy="7118839"/>
+            <a:off x="527168" y="25771993"/>
+            <a:ext cx="13540269" cy="6917558"/>
           </a:xfrm>
           <a:prstGeom prst="rect">
             <a:avLst/>
@@ -6284,10 +6248,10 @@
       </p:pic>
       <p:pic>
         <p:nvPicPr>
-          <p:cNvPr id="19" name="Imagem 18" descr="Tela de computador com texto preto sobre fundo branco&#10;&#10;O conteúdo gerado por IA pode estar incorreto.">
+          <p:cNvPr id="3" name="Imagem 2" descr="Logotipo&#10;&#10;O conteúdo gerado por IA pode estar incorreto.">
             <a:extLst>
               <a:ext uri="{FF2B5EF4-FFF2-40B4-BE49-F238E27FC236}">
-                <a16:creationId xmlns:a16="http://schemas.microsoft.com/office/drawing/2014/main" id="{13F7082B-92CB-7E03-BC65-E8169822B6AC}"/>
+                <a16:creationId xmlns:a16="http://schemas.microsoft.com/office/drawing/2014/main" id="{EF2D7B80-B4C7-90CE-1482-6F38D90C86E7}"/>
               </a:ext>
             </a:extLst>
           </p:cNvPr>
@@ -6304,21 +6268,92 @@
               </a:ext>
             </a:extLst>
           </a:blip>
-          <a:srcRect l="9913" r="10102"/>
+          <a:srcRect l="10283" r="9733"/>
           <a:stretch>
             <a:fillRect/>
           </a:stretch>
         </p:blipFill>
         <p:spPr>
           <a:xfrm>
-            <a:off x="1207403" y="24385100"/>
-            <a:ext cx="12653251" cy="7118840"/>
+            <a:off x="527788" y="17966653"/>
+            <a:ext cx="13447585" cy="7404610"/>
           </a:xfrm>
           <a:prstGeom prst="rect">
             <a:avLst/>
           </a:prstGeom>
         </p:spPr>
       </p:pic>
+      <p:sp>
+        <p:nvSpPr>
+          <p:cNvPr id="12" name="Retângulo 11">
+            <a:extLst>
+              <a:ext uri="{FF2B5EF4-FFF2-40B4-BE49-F238E27FC236}">
+                <a16:creationId xmlns:a16="http://schemas.microsoft.com/office/drawing/2014/main" id="{74E9C4D9-2DF3-430D-9D26-B87735ECD4E8}"/>
+              </a:ext>
+            </a:extLst>
+          </p:cNvPr>
+          <p:cNvSpPr/>
+          <p:nvPr/>
+        </p:nvSpPr>
+        <p:spPr bwMode="auto">
+          <a:xfrm>
+            <a:off x="10610784" y="24048591"/>
+            <a:ext cx="2901561" cy="682016"/>
+          </a:xfrm>
+          <a:prstGeom prst="rect">
+            <a:avLst/>
+          </a:prstGeom>
+          <a:solidFill>
+            <a:srgbClr val="010101"/>
+          </a:solidFill>
+          <a:ln w="9525" cap="flat" cmpd="sng" algn="ctr">
+            <a:solidFill>
+              <a:srgbClr val="000000"/>
+            </a:solidFill>
+            <a:prstDash val="solid"/>
+            <a:round/>
+            <a:headEnd type="none" w="med" len="med"/>
+            <a:tailEnd type="none" w="med" len="med"/>
+          </a:ln>
+          <a:effectLst/>
+        </p:spPr>
+        <p:txBody>
+          <a:bodyPr vert="horz" wrap="square" lIns="91440" tIns="45720" rIns="91440" bIns="45720" numCol="1" rtlCol="0" anchor="t" anchorCtr="0" compatLnSpc="1">
+            <a:prstTxWarp prst="textNoShape">
+              <a:avLst/>
+            </a:prstTxWarp>
+          </a:bodyPr>
+          <a:lstStyle/>
+          <a:p>
+            <a:pPr marL="0" marR="0" indent="0" algn="l" defTabSz="3086100" rtl="0" eaLnBrk="1" fontAlgn="base" latinLnBrk="0" hangingPunct="1">
+              <a:lnSpc>
+                <a:spcPct val="100000"/>
+              </a:lnSpc>
+              <a:spcBef>
+                <a:spcPct val="0"/>
+              </a:spcBef>
+              <a:spcAft>
+                <a:spcPct val="0"/>
+              </a:spcAft>
+              <a:buClrTx/>
+              <a:buSzTx/>
+              <a:buFontTx/>
+              <a:buNone/>
+              <a:tabLst/>
+            </a:pPr>
+            <a:endParaRPr kumimoji="0" lang="pt-BR" sz="6100" b="0" i="0" u="none" strike="noStrike" cap="none" normalizeH="0" baseline="0">
+              <a:ln>
+                <a:noFill/>
+              </a:ln>
+              <a:solidFill>
+                <a:schemeClr val="tx1"/>
+              </a:solidFill>
+              <a:effectLst/>
+              <a:latin typeface="Arial" charset="0"/>
+            </a:endParaRPr>
+          </a:p>
+        </p:txBody>
+      </p:sp>
     </p:spTree>
     <p:extLst>
       <p:ext uri="{BB962C8B-B14F-4D97-AF65-F5344CB8AC3E}">
@@ -7742,15 +7777,6 @@
 </file>
 
 <file path=customXml/item1.xml><?xml version="1.0" encoding="utf-8"?>
-<?mso-contentType ?>
-<FormTemplates xmlns="http://schemas.microsoft.com/sharepoint/v3/contenttype/forms">
-  <Display>DocumentLibraryForm</Display>
-  <Edit>DocumentLibraryForm</Edit>
-  <New>DocumentLibraryForm</New>
-</FormTemplates>
-</file>
-
-<file path=customXml/item2.xml><?xml version="1.0" encoding="utf-8"?>
 <ct:contentTypeSchema xmlns:ct="http://schemas.microsoft.com/office/2006/metadata/contentType" xmlns:ma="http://schemas.microsoft.com/office/2006/metadata/properties/metaAttributes" ct:_="" ma:_="" ma:contentTypeName="Documento" ma:contentTypeID="0x01010045364877AF745B4281652B53F43C594A" ma:contentTypeVersion="15" ma:contentTypeDescription="Crie um novo documento." ma:contentTypeScope="" ma:versionID="440a6fbbcbce65e3f8e2bed610644788">
   <xsd:schema xmlns:xsd="http://www.w3.org/2001/XMLSchema" xmlns:xs="http://www.w3.org/2001/XMLSchema" xmlns:p="http://schemas.microsoft.com/office/2006/metadata/properties" xmlns:ns2="1d2798d9-1030-4cc5-be7b-200f9e628651" xmlns:ns3="8ca2a57e-8138-4b57-956a-eb6e2c7049cc" targetNamespace="http://schemas.microsoft.com/office/2006/metadata/properties" ma:root="true" ma:fieldsID="3ff20d9b6411658b7762fa2c08d7e1af" ns2:_="" ns3:_="">
     <xsd:import namespace="1d2798d9-1030-4cc5-be7b-200f9e628651"/>
@@ -7985,6 +8011,15 @@
 </ct:contentTypeSchema>
 </file>
 
+<file path=customXml/item2.xml><?xml version="1.0" encoding="utf-8"?>
+<?mso-contentType ?>
+<FormTemplates xmlns="http://schemas.microsoft.com/sharepoint/v3/contenttype/forms">
+  <Display>DocumentLibraryForm</Display>
+  <Edit>DocumentLibraryForm</Edit>
+  <New>DocumentLibraryForm</New>
+</FormTemplates>
+</file>
+
 <file path=customXml/item3.xml><?xml version="1.0" encoding="utf-8"?>
 <p:properties xmlns:p="http://schemas.microsoft.com/office/2006/metadata/properties" xmlns:xsi="http://www.w3.org/2001/XMLSchema-instance" xmlns:pc="http://schemas.microsoft.com/office/infopath/2007/PartnerControls">
   <documentManagement>
@@ -7997,14 +8032,6 @@
 </file>
 
 <file path=customXml/itemProps1.xml><?xml version="1.0" encoding="utf-8"?>
-<ds:datastoreItem xmlns:ds="http://schemas.openxmlformats.org/officeDocument/2006/customXml" ds:itemID="{20511531-72C6-41EA-909D-35A50B0891E1}">
-  <ds:schemaRefs>
-    <ds:schemaRef ds:uri="http://schemas.microsoft.com/sharepoint/v3/contenttype/forms"/>
-  </ds:schemaRefs>
-</ds:datastoreItem>
-</file>
-
-<file path=customXml/itemProps2.xml><?xml version="1.0" encoding="utf-8"?>
 <ds:datastoreItem xmlns:ds="http://schemas.openxmlformats.org/officeDocument/2006/customXml" ds:itemID="{B0583F25-0BD0-426F-9D18-6079E5A02729}">
   <ds:schemaRefs>
     <ds:schemaRef ds:uri="http://schemas.microsoft.com/office/2006/metadata/contentType"/>
@@ -8023,19 +8050,27 @@
 </ds:datastoreItem>
 </file>
 
+<file path=customXml/itemProps2.xml><?xml version="1.0" encoding="utf-8"?>
+<ds:datastoreItem xmlns:ds="http://schemas.openxmlformats.org/officeDocument/2006/customXml" ds:itemID="{20511531-72C6-41EA-909D-35A50B0891E1}">
+  <ds:schemaRefs>
+    <ds:schemaRef ds:uri="http://schemas.microsoft.com/sharepoint/v3/contenttype/forms"/>
+  </ds:schemaRefs>
+</ds:datastoreItem>
+</file>
+
 <file path=customXml/itemProps3.xml><?xml version="1.0" encoding="utf-8"?>
 <ds:datastoreItem xmlns:ds="http://schemas.openxmlformats.org/officeDocument/2006/customXml" ds:itemID="{8C580D08-C850-4D98-9BB0-6190D1509D8A}">
   <ds:schemaRefs>
-    <ds:schemaRef ds:uri="http://www.w3.org/XML/1998/namespace"/>
-    <ds:schemaRef ds:uri="1d2798d9-1030-4cc5-be7b-200f9e628651"/>
-    <ds:schemaRef ds:uri="http://purl.org/dc/elements/1.1/"/>
+    <ds:schemaRef ds:uri="http://purl.org/dc/terms/"/>
     <ds:schemaRef ds:uri="http://schemas.microsoft.com/office/2006/documentManagement/types"/>
+    <ds:schemaRef ds:uri="8ca2a57e-8138-4b57-956a-eb6e2c7049cc"/>
     <ds:schemaRef ds:uri="http://purl.org/dc/dcmitype/"/>
-    <ds:schemaRef ds:uri="http://schemas.microsoft.com/office/2006/metadata/properties"/>
     <ds:schemaRef ds:uri="http://schemas.microsoft.com/office/infopath/2007/PartnerControls"/>
     <ds:schemaRef ds:uri="http://schemas.openxmlformats.org/package/2006/metadata/core-properties"/>
-    <ds:schemaRef ds:uri="8ca2a57e-8138-4b57-956a-eb6e2c7049cc"/>
-    <ds:schemaRef ds:uri="http://purl.org/dc/terms/"/>
+    <ds:schemaRef ds:uri="http://purl.org/dc/elements/1.1/"/>
+    <ds:schemaRef ds:uri="1d2798d9-1030-4cc5-be7b-200f9e628651"/>
+    <ds:schemaRef ds:uri="http://schemas.microsoft.com/office/2006/metadata/properties"/>
+    <ds:schemaRef ds:uri="http://www.w3.org/XML/1998/namespace"/>
   </ds:schemaRefs>
 </ds:datastoreItem>
 </file>
</xml_diff>